<commit_message>
final final add (the technical report)
</commit_message>
<xml_diff>
--- a/submission_presentation.pptx
+++ b/submission_presentation.pptx
@@ -10,7 +10,6 @@
     <p:sldId id="258" r:id="rId9"/>
     <p:sldId id="259" r:id="rId10"/>
     <p:sldId id="260" r:id="rId11"/>
-    <p:sldId id="261" r:id="rId12"/>
   </p:sldIdLst>
   <p:sldSz cx="12191695" cy="6858000" type="screen4x3"/>
   <p:notesSz cx="6858000" cy="9144000"/>
@@ -3392,238 +3391,6 @@
                   <a:srgbClr val="142850"/>
                 </a:solidFill>
               </a:rPr>
-              <a:t>Version Control Practices and Commit History</a:t>
-            </a:r>
-          </a:p>
-        </p:txBody>
-      </p:sp>
-      <p:sp>
-        <p:nvSpPr>
-          <p:cNvPr id="3" name="TextBox 2"/>
-          <p:cNvSpPr txBox="1"/>
-          <p:nvPr/>
-        </p:nvSpPr>
-        <p:spPr>
-          <a:xfrm>
-            <a:off x="731520" y="914400"/>
-            <a:ext cx="10698480" cy="438912"/>
-          </a:xfrm>
-          <a:prstGeom prst="rect">
-            <a:avLst/>
-          </a:prstGeom>
-          <a:noFill/>
-        </p:spPr>
-        <p:txBody>
-          <a:bodyPr wrap="none">
-            <a:spAutoFit/>
-          </a:bodyPr>
-          <a:lstStyle/>
-          <a:p>
-            <a:pPr algn="ctr"/>
-            <a:r>
-              <a:rPr sz="1400">
-                <a:solidFill>
-                  <a:srgbClr val="5A5A5A"/>
-                </a:solidFill>
-              </a:rPr>
-              <a:t>Repository details can be left blank for now</a:t>
-            </a:r>
-          </a:p>
-        </p:txBody>
-      </p:sp>
-      <p:sp>
-        <p:nvSpPr>
-          <p:cNvPr id="4" name="Rectangle 3"/>
-          <p:cNvSpPr/>
-          <p:nvPr/>
-        </p:nvSpPr>
-        <p:spPr>
-          <a:xfrm>
-            <a:off x="914400" y="1600200"/>
-            <a:ext cx="10332720" cy="4206240"/>
-          </a:xfrm>
-          <a:prstGeom prst="rect">
-            <a:avLst/>
-          </a:prstGeom>
-          <a:solidFill>
-            <a:srgbClr val="FFFFFF"/>
-          </a:solidFill>
-          <a:ln>
-            <a:solidFill>
-              <a:srgbClr val="C8CDD2"/>
-            </a:solidFill>
-          </a:ln>
-        </p:spPr>
-        <p:style>
-          <a:lnRef idx="1">
-            <a:schemeClr val="accent1"/>
-          </a:lnRef>
-          <a:fillRef idx="3">
-            <a:schemeClr val="accent1"/>
-          </a:fillRef>
-          <a:effectRef idx="2">
-            <a:schemeClr val="accent1"/>
-          </a:effectRef>
-          <a:fontRef idx="minor">
-            <a:schemeClr val="lt1"/>
-          </a:fontRef>
-        </p:style>
-        <p:txBody>
-          <a:bodyPr rtlCol="0" anchor="ctr" wrap="square">
-            <a:normAutofit/>
-          </a:bodyPr>
-          <a:lstStyle/>
-          <a:p>
-            <a:pPr algn="l">
-              <a:spcAft>
-                <a:spcPts val="700"/>
-              </a:spcAft>
-            </a:pPr>
-            <a:r>
-              <a:rPr sz="1900">
-                <a:solidFill>
-                  <a:srgbClr val="191919"/>
-                </a:solidFill>
-              </a:rPr>
-              <a:t>• Repository link intentionally left blank.</a:t>
-            </a:r>
-          </a:p>
-          <a:p>
-            <a:pPr algn="l">
-              <a:spcAft>
-                <a:spcPts val="700"/>
-              </a:spcAft>
-            </a:pPr>
-            <a:r>
-              <a:rPr sz="1900">
-                <a:solidFill>
-                  <a:srgbClr val="191919"/>
-                </a:solidFill>
-              </a:rPr>
-              <a:t>• Add your real repository URL later if needed.</a:t>
-            </a:r>
-          </a:p>
-          <a:p>
-            <a:pPr algn="l">
-              <a:spcAft>
-                <a:spcPts val="700"/>
-              </a:spcAft>
-            </a:pPr>
-            <a:r>
-              <a:rPr sz="1900">
-                <a:solidFill>
-                  <a:srgbClr val="191919"/>
-                </a:solidFill>
-              </a:rPr>
-              <a:t>• Summarise branch usage, commit discipline, and implementation milestones.</a:t>
-            </a:r>
-          </a:p>
-          <a:p>
-            <a:pPr algn="l">
-              <a:spcAft>
-                <a:spcPts val="700"/>
-              </a:spcAft>
-            </a:pPr>
-            <a:r>
-              <a:rPr sz="1900">
-                <a:solidFill>
-                  <a:srgbClr val="191919"/>
-                </a:solidFill>
-              </a:rPr>
-              <a:t>• Mention debugging, refactoring, and feature progression across commits.</a:t>
-            </a:r>
-          </a:p>
-        </p:txBody>
-      </p:sp>
-      <p:sp>
-        <p:nvSpPr>
-          <p:cNvPr id="5" name="TextBox 4"/>
-          <p:cNvSpPr txBox="1"/>
-          <p:nvPr/>
-        </p:nvSpPr>
-        <p:spPr>
-          <a:xfrm>
-            <a:off x="457200" y="6245352"/>
-            <a:ext cx="11247120" cy="292608"/>
-          </a:xfrm>
-          <a:prstGeom prst="rect">
-            <a:avLst/>
-          </a:prstGeom>
-          <a:noFill/>
-        </p:spPr>
-        <p:txBody>
-          <a:bodyPr wrap="none">
-            <a:spAutoFit/>
-          </a:bodyPr>
-          <a:lstStyle/>
-          <a:p>
-            <a:pPr algn="r"/>
-            <a:r>
-              <a:rPr sz="1000">
-                <a:solidFill>
-                  <a:srgbClr val="787878"/>
-                </a:solidFill>
-              </a:rPr>
-              <a:t>Slide 2 of 5</a:t>
-            </a:r>
-          </a:p>
-        </p:txBody>
-      </p:sp>
-    </p:spTree>
-  </p:cSld>
-  <p:clrMapOvr>
-    <a:masterClrMapping/>
-  </p:clrMapOvr>
-</p:sld>
-</file>
-
-<file path=ppt/slides/slide3.xml><?xml version="1.0" encoding="utf-8"?>
-<p:sld xmlns:a="http://schemas.openxmlformats.org/drawingml/2006/main" xmlns:p="http://schemas.openxmlformats.org/presentationml/2006/main" xmlns:r="http://schemas.openxmlformats.org/officeDocument/2006/relationships">
-  <p:cSld>
-    <p:bg>
-      <p:bgPr>
-        <a:solidFill>
-          <a:srgbClr val="F5F7FA"/>
-        </a:solidFill>
-        <a:effectLst/>
-      </p:bgPr>
-    </p:bg>
-    <p:spTree>
-      <p:nvGrpSpPr>
-        <p:cNvPr id="1" name=""/>
-        <p:cNvGrpSpPr/>
-        <p:nvPr/>
-      </p:nvGrpSpPr>
-      <p:grpSpPr/>
-      <p:sp>
-        <p:nvSpPr>
-          <p:cNvPr id="2" name="TextBox 1"/>
-          <p:cNvSpPr txBox="1"/>
-          <p:nvPr/>
-        </p:nvSpPr>
-        <p:spPr>
-          <a:xfrm>
-            <a:off x="548640" y="256032"/>
-            <a:ext cx="11064240" cy="731520"/>
-          </a:xfrm>
-          <a:prstGeom prst="rect">
-            <a:avLst/>
-          </a:prstGeom>
-          <a:noFill/>
-        </p:spPr>
-        <p:txBody>
-          <a:bodyPr wrap="none">
-            <a:spAutoFit/>
-          </a:bodyPr>
-          <a:lstStyle/>
-          <a:p>
-            <a:pPr algn="ctr"/>
-            <a:r>
-              <a:rPr sz="2700" b="1">
-                <a:solidFill>
-                  <a:srgbClr val="142850"/>
-                </a:solidFill>
-              </a:rPr>
               <a:t>Version Control Practices and Commit Hist`ory</a:t>
             </a:r>
           </a:p>
@@ -3742,7 +3509,7 @@
 </p:sld>
 </file>
 
-<file path=ppt/slides/slide4.xml><?xml version="1.0" encoding="utf-8"?>
+<file path=ppt/slides/slide3.xml><?xml version="1.0" encoding="utf-8"?>
 <p:sld xmlns:a="http://schemas.openxmlformats.org/drawingml/2006/main" xmlns:p="http://schemas.openxmlformats.org/presentationml/2006/main" xmlns:r="http://schemas.openxmlformats.org/officeDocument/2006/relationships">
   <p:cSld>
     <p:bg>
@@ -3974,7 +3741,7 @@
 </p:sld>
 </file>
 
-<file path=ppt/slides/slide5.xml><?xml version="1.0" encoding="utf-8"?>
+<file path=ppt/slides/slide4.xml><?xml version="1.0" encoding="utf-8"?>
 <p:sld xmlns:a="http://schemas.openxmlformats.org/drawingml/2006/main" xmlns:p="http://schemas.openxmlformats.org/presentationml/2006/main" xmlns:r="http://schemas.openxmlformats.org/officeDocument/2006/relationships">
   <p:cSld>
     <p:bg>
@@ -4191,7 +3958,7 @@
 </p:sld>
 </file>
 
-<file path=ppt/slides/slide6.xml><?xml version="1.0" encoding="utf-8"?>
+<file path=ppt/slides/slide5.xml><?xml version="1.0" encoding="utf-8"?>
 <p:sld xmlns:a="http://schemas.openxmlformats.org/drawingml/2006/main" xmlns:p="http://schemas.openxmlformats.org/presentationml/2006/main" xmlns:r="http://schemas.openxmlformats.org/officeDocument/2006/relationships">
   <p:cSld>
     <p:bg>

</xml_diff>